<commit_message>
feat(slides): optimize slide typography and readability for presentation, condense text, and regenerate all PPTX presentations
</commit_message>
<xml_diff>
--- a/docs/MultiThreading_Patterns_PTIT_T45_Editable.pptx
+++ b/docs/MultiThreading_Patterns_PTIT_T45_Editable.pptx
@@ -19390,11 +19390,11 @@
         <p:spPr>
           <a:xfrm>
             <a:off x="777240" y="3145536"/>
-            <a:ext cx="2409444" cy="868680"/>
+            <a:ext cx="4956048" cy="841248"/>
           </a:xfrm>
           <a:prstGeom prst="roundRect">
             <a:avLst>
-              <a:gd name="adj" fmla="val 8421"/>
+              <a:gd name="adj" fmla="val 8696"/>
             </a:avLst>
           </a:prstGeom>
           <a:solidFill>
@@ -19417,42 +19417,42 @@
         <p:spPr>
           <a:xfrm>
             <a:off x="868680" y="3218688"/>
-            <a:ext cx="2226564" cy="722376"/>
-          </a:xfrm>
-          <a:prstGeom prst="rect">
-            <a:avLst/>
-          </a:prstGeom>
-          <a:noFill/>
-          <a:ln/>
-        </p:spPr>
-        <p:txBody>
-          <a:bodyPr wrap="square" lIns="25400" tIns="50800" rIns="50800" bIns="25400" rtlCol="0" anchor="t"/>
-          <a:lstStyle/>
-          <a:p>
-            <a:pPr indent="0" marL="0">
-              <a:buNone/>
-            </a:pPr>
-            <a:r>
-              <a:rPr lang="en-US" sz="1000" b="1" dirty="0">
+            <a:ext cx="4773168" cy="694944"/>
+          </a:xfrm>
+          <a:prstGeom prst="rect">
+            <a:avLst/>
+          </a:prstGeom>
+          <a:noFill/>
+          <a:ln/>
+        </p:spPr>
+        <p:txBody>
+          <a:bodyPr wrap="square" lIns="25400" tIns="76200" rIns="76200" bIns="25400" rtlCol="0" anchor="ctr"/>
+          <a:lstStyle/>
+          <a:p>
+            <a:pPr indent="0" marL="0">
+              <a:buNone/>
+            </a:pPr>
+            <a:r>
+              <a:rPr lang="en-US" sz="1100" b="1" dirty="0">
                 <a:solidFill>
                   <a:srgbClr val="0F172A"/>
                 </a:solidFill>
               </a:rPr>
-              <a:t>💤 Lãng Phí Tài Nguyên
+              <a:t>💤  Lãng Phí Stack 1MB
 </a:t>
             </a:r>
             <a:pPr indent="0" marL="0">
               <a:buNone/>
             </a:pPr>
             <a:r>
-              <a:rPr lang="en-US" sz="850" dirty="0">
+              <a:rPr lang="en-US" sz="920" dirty="0">
                 <a:solidFill>
                   <a:srgbClr val="334155"/>
                 </a:solidFill>
               </a:rPr>
-              <a:t>CPU nhàn rỗi tuyệt đối nhưng bộ nhớ Stack 1MB vẫn bị giam giữ cứng ngắc.</a:t>
-            </a:r>
-            <a:endParaRPr lang="en-US" sz="1000" dirty="0"/>
+              <a:t>CPU nhàn rỗi 96% nhưng vẫn giam cứng 1MB RAM/luồng chỉ để đứng chờ mạng.</a:t>
+            </a:r>
+            <a:endParaRPr lang="en-US" sz="1100" dirty="0"/>
           </a:p>
         </p:txBody>
       </p:sp>
@@ -19464,12 +19464,12 @@
         </p:nvSpPr>
         <p:spPr>
           <a:xfrm>
-            <a:off x="3323844" y="3145536"/>
-            <a:ext cx="2409444" cy="868680"/>
+            <a:off x="777240" y="4078224"/>
+            <a:ext cx="4956048" cy="841248"/>
           </a:xfrm>
           <a:prstGeom prst="roundRect">
             <a:avLst>
-              <a:gd name="adj" fmla="val 8421"/>
+              <a:gd name="adj" fmla="val 8696"/>
             </a:avLst>
           </a:prstGeom>
           <a:solidFill>
@@ -19491,43 +19491,43 @@
         </p:nvSpPr>
         <p:spPr>
           <a:xfrm>
-            <a:off x="3415284" y="3218688"/>
-            <a:ext cx="2226564" cy="722376"/>
-          </a:xfrm>
-          <a:prstGeom prst="rect">
-            <a:avLst/>
-          </a:prstGeom>
-          <a:noFill/>
-          <a:ln/>
-        </p:spPr>
-        <p:txBody>
-          <a:bodyPr wrap="square" lIns="25400" tIns="50800" rIns="50800" bIns="25400" rtlCol="0" anchor="t"/>
-          <a:lstStyle/>
-          <a:p>
-            <a:pPr indent="0" marL="0">
-              <a:buNone/>
-            </a:pPr>
-            <a:r>
-              <a:rPr lang="en-US" sz="1000" b="1" dirty="0">
+            <a:off x="868680" y="4151376"/>
+            <a:ext cx="4773168" cy="694944"/>
+          </a:xfrm>
+          <a:prstGeom prst="rect">
+            <a:avLst/>
+          </a:prstGeom>
+          <a:noFill/>
+          <a:ln/>
+        </p:spPr>
+        <p:txBody>
+          <a:bodyPr wrap="square" lIns="25400" tIns="76200" rIns="76200" bIns="25400" rtlCol="0" anchor="ctr"/>
+          <a:lstStyle/>
+          <a:p>
+            <a:pPr indent="0" marL="0">
+              <a:buNone/>
+            </a:pPr>
+            <a:r>
+              <a:rPr lang="en-US" sz="1100" b="1" dirty="0">
                 <a:solidFill>
                   <a:srgbClr val="0F172A"/>
                 </a:solidFill>
               </a:rPr>
-              <a:t>🧱 Nghẽn Kết Nối C10K
+              <a:t>🧱  Nghẽn C10K Sập Máy Chủ
 </a:t>
             </a:r>
             <a:pPr indent="0" marL="0">
               <a:buNone/>
             </a:pPr>
             <a:r>
-              <a:rPr lang="en-US" sz="850" dirty="0">
+              <a:rPr lang="en-US" sz="920" dirty="0">
                 <a:solidFill>
                   <a:srgbClr val="334155"/>
                 </a:solidFill>
               </a:rPr>
-              <a:t>Tạo 10,000 luồng tương đương ngốn 10GB RAM chỉ để đứng chờ mạng đến.</a:t>
-            </a:r>
-            <a:endParaRPr lang="en-US" sz="1000" dirty="0"/>
+              <a:t>10,000 kết nối ngốn tới 10GB RAM chỉ để ngủ đông, làm kiệt quệ hệ thống.</a:t>
+            </a:r>
+            <a:endParaRPr lang="en-US" sz="1100" dirty="0"/>
           </a:p>
         </p:txBody>
       </p:sp>
@@ -19539,12 +19539,447 @@
         </p:nvSpPr>
         <p:spPr>
           <a:xfrm>
-            <a:off x="777240" y="4105656"/>
-            <a:ext cx="2409444" cy="868680"/>
+            <a:off x="777240" y="5084064"/>
+            <a:ext cx="4956048" cy="365760"/>
           </a:xfrm>
           <a:prstGeom prst="roundRect">
             <a:avLst>
-              <a:gd name="adj" fmla="val 8421"/>
+              <a:gd name="adj" fmla="val 20000"/>
+            </a:avLst>
+          </a:prstGeom>
+          <a:solidFill>
+            <a:srgbClr val="EFF6FF"/>
+          </a:solidFill>
+          <a:ln w="12700">
+            <a:solidFill>
+              <a:srgbClr val="BFDBFE"/>
+            </a:solidFill>
+            <a:prstDash val="solid"/>
+          </a:ln>
+        </p:spPr>
+      </p:sp>
+      <p:sp>
+        <p:nvSpPr>
+          <p:cNvPr id="27" name="Text 25"/>
+          <p:cNvSpPr/>
+          <p:nvPr/>
+        </p:nvSpPr>
+        <p:spPr>
+          <a:xfrm>
+            <a:off x="868680" y="5084064"/>
+            <a:ext cx="4773168" cy="365760"/>
+          </a:xfrm>
+          <a:prstGeom prst="rect">
+            <a:avLst/>
+          </a:prstGeom>
+          <a:noFill/>
+          <a:ln/>
+        </p:spPr>
+        <p:txBody>
+          <a:bodyPr wrap="square" rtlCol="0" anchor="ctr"/>
+          <a:lstStyle/>
+          <a:p>
+            <a:pPr indent="0" marL="0">
+              <a:buNone/>
+            </a:pPr>
+            <a:r>
+              <a:rPr lang="en-US" sz="880" b="1" dirty="0">
+                <a:solidFill>
+                  <a:srgbClr val="1D4ED8"/>
+                </a:solidFill>
+                <a:latin typeface="Arial" pitchFamily="34" charset="0"/>
+                <a:ea typeface="Arial" pitchFamily="34" charset="-122"/>
+                <a:cs typeface="Arial" pitchFamily="34" charset="-120"/>
+              </a:rPr>
+              <a:t>🚀 Sân khấu chính: Nơi Thread Pool &amp; Virtual Threads giải phóng sức mạnh máy chủ</a:t>
+            </a:r>
+            <a:endParaRPr lang="en-US" sz="880" dirty="0"/>
+          </a:p>
+        </p:txBody>
+      </p:sp>
+      <p:sp>
+        <p:nvSpPr>
+          <p:cNvPr id="28" name="Shape 26"/>
+          <p:cNvSpPr/>
+          <p:nvPr/>
+        </p:nvSpPr>
+        <p:spPr>
+          <a:xfrm>
+            <a:off x="6227064" y="1536192"/>
+            <a:ext cx="5413248" cy="4023360"/>
+          </a:xfrm>
+          <a:prstGeom prst="roundRect">
+            <a:avLst>
+              <a:gd name="adj" fmla="val 2273"/>
+            </a:avLst>
+          </a:prstGeom>
+          <a:solidFill>
+            <a:srgbClr val="FFFFFF"/>
+          </a:solidFill>
+          <a:ln w="19050">
+            <a:solidFill>
+              <a:srgbClr val="CBD5E1"/>
+            </a:solidFill>
+            <a:prstDash val="solid"/>
+          </a:ln>
+        </p:spPr>
+      </p:sp>
+      <p:sp>
+        <p:nvSpPr>
+          <p:cNvPr id="29" name="Shape 27"/>
+          <p:cNvSpPr/>
+          <p:nvPr/>
+        </p:nvSpPr>
+        <p:spPr>
+          <a:xfrm>
+            <a:off x="6227064" y="1536192"/>
+            <a:ext cx="5413248" cy="73152"/>
+          </a:xfrm>
+          <a:prstGeom prst="roundRect">
+            <a:avLst/>
+          </a:prstGeom>
+          <a:solidFill>
+            <a:srgbClr val="E11D48"/>
+          </a:solidFill>
+          <a:ln w="12700">
+            <a:solidFill>
+              <a:srgbClr val="E11D48"/>
+            </a:solidFill>
+            <a:prstDash val="solid"/>
+          </a:ln>
+        </p:spPr>
+      </p:sp>
+      <p:sp>
+        <p:nvSpPr>
+          <p:cNvPr id="30" name="Text 28"/>
+          <p:cNvSpPr/>
+          <p:nvPr/>
+        </p:nvSpPr>
+        <p:spPr>
+          <a:xfrm>
+            <a:off x="6455664" y="1673352"/>
+            <a:ext cx="3767328" cy="320040"/>
+          </a:xfrm>
+          <a:prstGeom prst="rect">
+            <a:avLst/>
+          </a:prstGeom>
+          <a:noFill/>
+          <a:ln/>
+        </p:spPr>
+        <p:txBody>
+          <a:bodyPr wrap="square" rtlCol="0" anchor="ctr"/>
+          <a:lstStyle/>
+          <a:p>
+            <a:pPr indent="0" marL="0">
+              <a:buNone/>
+            </a:pPr>
+            <a:r>
+              <a:rPr lang="en-US" sz="1450" b="1" dirty="0">
+                <a:solidFill>
+                  <a:srgbClr val="0F172A"/>
+                </a:solidFill>
+                <a:latin typeface="Arial" pitchFamily="34" charset="0"/>
+                <a:ea typeface="Arial" pitchFamily="34" charset="-122"/>
+                <a:cs typeface="Arial" pitchFamily="34" charset="-120"/>
+              </a:rPr>
+              <a:t>⚙️  Tác Vụ CPU-Bound</a:t>
+            </a:r>
+            <a:endParaRPr lang="en-US" sz="1450" dirty="0"/>
+          </a:p>
+        </p:txBody>
+      </p:sp>
+      <p:sp>
+        <p:nvSpPr>
+          <p:cNvPr id="31" name="Text 29"/>
+          <p:cNvSpPr/>
+          <p:nvPr/>
+        </p:nvSpPr>
+        <p:spPr>
+          <a:xfrm>
+            <a:off x="6455664" y="1993392"/>
+            <a:ext cx="3767328" cy="256032"/>
+          </a:xfrm>
+          <a:prstGeom prst="rect">
+            <a:avLst/>
+          </a:prstGeom>
+          <a:noFill/>
+          <a:ln/>
+        </p:spPr>
+        <p:txBody>
+          <a:bodyPr wrap="square" rtlCol="0" anchor="t"/>
+          <a:lstStyle/>
+          <a:p>
+            <a:pPr indent="0" marL="0">
+              <a:buNone/>
+            </a:pPr>
+            <a:r>
+              <a:rPr lang="en-US" sz="950" b="1" dirty="0">
+                <a:solidFill>
+                  <a:srgbClr val="334155"/>
+                </a:solidFill>
+                <a:latin typeface="Arial" pitchFamily="34" charset="0"/>
+                <a:ea typeface="Arial" pitchFamily="34" charset="-122"/>
+                <a:cs typeface="Arial" pitchFamily="34" charset="-120"/>
+              </a:rPr>
+              <a:t>Mã hóa SSL/TLS, Nén dữ liệu gzip, Thuật toán</a:t>
+            </a:r>
+            <a:endParaRPr lang="en-US" sz="950" dirty="0"/>
+          </a:p>
+        </p:txBody>
+      </p:sp>
+      <p:sp>
+        <p:nvSpPr>
+          <p:cNvPr id="32" name="Shape 30"/>
+          <p:cNvSpPr/>
+          <p:nvPr/>
+        </p:nvSpPr>
+        <p:spPr>
+          <a:xfrm>
+            <a:off x="9948672" y="1719072"/>
+            <a:ext cx="1463040" cy="256032"/>
+          </a:xfrm>
+          <a:prstGeom prst="roundRect">
+            <a:avLst>
+              <a:gd name="adj" fmla="val 35714"/>
+            </a:avLst>
+          </a:prstGeom>
+          <a:solidFill>
+            <a:srgbClr val="FFF1F2"/>
+          </a:solidFill>
+          <a:ln w="12700">
+            <a:solidFill>
+              <a:srgbClr val="FECDD3"/>
+            </a:solidFill>
+            <a:prstDash val="solid"/>
+          </a:ln>
+        </p:spPr>
+      </p:sp>
+      <p:sp>
+        <p:nvSpPr>
+          <p:cNvPr id="33" name="Text 31"/>
+          <p:cNvSpPr/>
+          <p:nvPr/>
+        </p:nvSpPr>
+        <p:spPr>
+          <a:xfrm>
+            <a:off x="9948672" y="1719072"/>
+            <a:ext cx="1463040" cy="256032"/>
+          </a:xfrm>
+          <a:prstGeom prst="rect">
+            <a:avLst/>
+          </a:prstGeom>
+          <a:noFill/>
+          <a:ln/>
+        </p:spPr>
+        <p:txBody>
+          <a:bodyPr wrap="square" rtlCol="0" anchor="ctr"/>
+          <a:lstStyle/>
+          <a:p>
+            <a:pPr algn="ctr" indent="0" marL="0">
+              <a:buNone/>
+            </a:pPr>
+            <a:r>
+              <a:rPr lang="en-US" sz="800" b="1" dirty="0">
+                <a:solidFill>
+                  <a:srgbClr val="E11D48"/>
+                </a:solidFill>
+                <a:latin typeface="Arial" pitchFamily="34" charset="0"/>
+                <a:ea typeface="Arial" pitchFamily="34" charset="-122"/>
+                <a:cs typeface="Arial" pitchFamily="34" charset="-120"/>
+              </a:rPr>
+              <a:t>10% — 20% TẢI MẠNG</a:t>
+            </a:r>
+            <a:endParaRPr lang="en-US" sz="800" dirty="0"/>
+          </a:p>
+        </p:txBody>
+      </p:sp>
+      <p:sp>
+        <p:nvSpPr>
+          <p:cNvPr id="34" name="Shape 32"/>
+          <p:cNvSpPr/>
+          <p:nvPr/>
+        </p:nvSpPr>
+        <p:spPr>
+          <a:xfrm>
+            <a:off x="6455664" y="2286000"/>
+            <a:ext cx="4956048" cy="0"/>
+          </a:xfrm>
+          <a:prstGeom prst="line">
+            <a:avLst/>
+          </a:prstGeom>
+          <a:noFill/>
+          <a:ln w="12700">
+            <a:solidFill>
+              <a:srgbClr val="F1F5F9"/>
+            </a:solidFill>
+            <a:prstDash val="solid"/>
+          </a:ln>
+        </p:spPr>
+      </p:sp>
+      <p:sp>
+        <p:nvSpPr>
+          <p:cNvPr id="35" name="Shape 33"/>
+          <p:cNvSpPr/>
+          <p:nvPr/>
+        </p:nvSpPr>
+        <p:spPr>
+          <a:xfrm>
+            <a:off x="6455664" y="2377440"/>
+            <a:ext cx="2386584" cy="658368"/>
+          </a:xfrm>
+          <a:prstGeom prst="roundRect">
+            <a:avLst>
+              <a:gd name="adj" fmla="val 11111"/>
+            </a:avLst>
+          </a:prstGeom>
+          <a:solidFill>
+            <a:srgbClr val="F8FAFC"/>
+          </a:solidFill>
+          <a:ln w="12700">
+            <a:solidFill>
+              <a:srgbClr val="CBD5E1"/>
+            </a:solidFill>
+            <a:prstDash val="solid"/>
+          </a:ln>
+        </p:spPr>
+      </p:sp>
+      <p:sp>
+        <p:nvSpPr>
+          <p:cNvPr id="36" name="Text 34"/>
+          <p:cNvSpPr/>
+          <p:nvPr/>
+        </p:nvSpPr>
+        <p:spPr>
+          <a:xfrm>
+            <a:off x="6547104" y="2432304"/>
+            <a:ext cx="2203704" cy="548640"/>
+          </a:xfrm>
+          <a:prstGeom prst="rect">
+            <a:avLst/>
+          </a:prstGeom>
+          <a:noFill/>
+          <a:ln/>
+        </p:spPr>
+        <p:txBody>
+          <a:bodyPr wrap="square" rtlCol="0" anchor="ctr"/>
+          <a:lstStyle/>
+          <a:p>
+            <a:pPr indent="0" marL="0">
+              <a:buNone/>
+            </a:pPr>
+            <a:r>
+              <a:rPr lang="en-US" sz="1600" b="1" dirty="0">
+                <a:solidFill>
+                  <a:srgbClr val="E11D48"/>
+                </a:solidFill>
+              </a:rPr>
+              <a:t>100%
+</a:t>
+            </a:r>
+            <a:pPr indent="0" marL="0">
+              <a:buNone/>
+            </a:pPr>
+            <a:r>
+              <a:rPr lang="en-US" sz="850" b="1" dirty="0">
+                <a:solidFill>
+                  <a:srgbClr val="334155"/>
+                </a:solidFill>
+              </a:rPr>
+              <a:t>Xung nhịp CPU hoạt động tối đa</a:t>
+            </a:r>
+            <a:endParaRPr lang="en-US" sz="1600" dirty="0"/>
+          </a:p>
+        </p:txBody>
+      </p:sp>
+      <p:sp>
+        <p:nvSpPr>
+          <p:cNvPr id="37" name="Shape 35"/>
+          <p:cNvSpPr/>
+          <p:nvPr/>
+        </p:nvSpPr>
+        <p:spPr>
+          <a:xfrm>
+            <a:off x="9025128" y="2377440"/>
+            <a:ext cx="2386584" cy="658368"/>
+          </a:xfrm>
+          <a:prstGeom prst="roundRect">
+            <a:avLst>
+              <a:gd name="adj" fmla="val 11111"/>
+            </a:avLst>
+          </a:prstGeom>
+          <a:solidFill>
+            <a:srgbClr val="F8FAFC"/>
+          </a:solidFill>
+          <a:ln w="12700">
+            <a:solidFill>
+              <a:srgbClr val="CBD5E1"/>
+            </a:solidFill>
+            <a:prstDash val="solid"/>
+          </a:ln>
+        </p:spPr>
+      </p:sp>
+      <p:sp>
+        <p:nvSpPr>
+          <p:cNvPr id="38" name="Text 36"/>
+          <p:cNvSpPr/>
+          <p:nvPr/>
+        </p:nvSpPr>
+        <p:spPr>
+          <a:xfrm>
+            <a:off x="9116568" y="2432304"/>
+            <a:ext cx="2203704" cy="548640"/>
+          </a:xfrm>
+          <a:prstGeom prst="rect">
+            <a:avLst/>
+          </a:prstGeom>
+          <a:noFill/>
+          <a:ln/>
+        </p:spPr>
+        <p:txBody>
+          <a:bodyPr wrap="square" rtlCol="0" anchor="ctr"/>
+          <a:lstStyle/>
+          <a:p>
+            <a:pPr indent="0" marL="0">
+              <a:buNone/>
+            </a:pPr>
+            <a:r>
+              <a:rPr lang="en-US" sz="1600" b="1" dirty="0">
+                <a:solidFill>
+                  <a:srgbClr val="E11D48"/>
+                </a:solidFill>
+              </a:rPr>
+              <a:t>N Lõi
+</a:t>
+            </a:r>
+            <a:pPr indent="0" marL="0">
+              <a:buNone/>
+            </a:pPr>
+            <a:r>
+              <a:rPr lang="en-US" sz="850" b="1" dirty="0">
+                <a:solidFill>
+                  <a:srgbClr val="334155"/>
+                </a:solidFill>
+              </a:rPr>
+              <a:t>Trần cứng giới hạn bởi số core vật lý</a:t>
+            </a:r>
+            <a:endParaRPr lang="en-US" sz="1600" dirty="0"/>
+          </a:p>
+        </p:txBody>
+      </p:sp>
+      <p:sp>
+        <p:nvSpPr>
+          <p:cNvPr id="39" name="Shape 37"/>
+          <p:cNvSpPr/>
+          <p:nvPr/>
+        </p:nvSpPr>
+        <p:spPr>
+          <a:xfrm>
+            <a:off x="6455664" y="3145536"/>
+            <a:ext cx="4956048" cy="841248"/>
+          </a:xfrm>
+          <a:prstGeom prst="roundRect">
+            <a:avLst>
+              <a:gd name="adj" fmla="val 8696"/>
             </a:avLst>
           </a:prstGeom>
           <a:solidFill>
@@ -19560,66 +19995,66 @@
       </p:sp>
       <p:sp>
         <p:nvSpPr>
-          <p:cNvPr id="27" name="Text 25"/>
-          <p:cNvSpPr/>
-          <p:nvPr/>
-        </p:nvSpPr>
-        <p:spPr>
-          <a:xfrm>
-            <a:off x="868680" y="4178808"/>
-            <a:ext cx="2226564" cy="722376"/>
-          </a:xfrm>
-          <a:prstGeom prst="rect">
-            <a:avLst/>
-          </a:prstGeom>
-          <a:noFill/>
-          <a:ln/>
-        </p:spPr>
-        <p:txBody>
-          <a:bodyPr wrap="square" lIns="25400" tIns="50800" rIns="50800" bIns="25400" rtlCol="0" anchor="t"/>
-          <a:lstStyle/>
-          <a:p>
-            <a:pPr indent="0" marL="0">
-              <a:buNone/>
-            </a:pPr>
-            <a:r>
-              <a:rPr lang="en-US" sz="1000" b="1" dirty="0">
+          <p:cNvPr id="40" name="Text 38"/>
+          <p:cNvSpPr/>
+          <p:nvPr/>
+        </p:nvSpPr>
+        <p:spPr>
+          <a:xfrm>
+            <a:off x="6547104" y="3218688"/>
+            <a:ext cx="4773168" cy="694944"/>
+          </a:xfrm>
+          <a:prstGeom prst="rect">
+            <a:avLst/>
+          </a:prstGeom>
+          <a:noFill/>
+          <a:ln/>
+        </p:spPr>
+        <p:txBody>
+          <a:bodyPr wrap="square" lIns="25400" tIns="76200" rIns="76200" bIns="25400" rtlCol="0" anchor="ctr"/>
+          <a:lstStyle/>
+          <a:p>
+            <a:pPr indent="0" marL="0">
+              <a:buNone/>
+            </a:pPr>
+            <a:r>
+              <a:rPr lang="en-US" sz="1100" b="1" dirty="0">
                 <a:solidFill>
                   <a:srgbClr val="0F172A"/>
                 </a:solidFill>
               </a:rPr>
-              <a:t>🎯 Mục Tiêu Tối Ưu
+              <a:t>🧱  Trần Lõi Vật Lý (N Core)
 </a:t>
             </a:r>
             <a:pPr indent="0" marL="0">
               <a:buNone/>
             </a:pPr>
             <a:r>
-              <a:rPr lang="en-US" sz="850" dirty="0">
+              <a:rPr lang="en-US" sz="920" dirty="0">
                 <a:solidFill>
                   <a:srgbClr val="334155"/>
                 </a:solidFill>
               </a:rPr>
-              <a:t>Tự động chuyển giao CPU ngay khi vào trạng thái chờ để phục vụ hàng ngàn kết nối.</a:t>
-            </a:r>
-            <a:endParaRPr lang="en-US" sz="1000" dirty="0"/>
-          </a:p>
-        </p:txBody>
-      </p:sp>
-      <p:sp>
-        <p:nvSpPr>
-          <p:cNvPr id="28" name="Shape 26"/>
-          <p:cNvSpPr/>
-          <p:nvPr/>
-        </p:nvSpPr>
-        <p:spPr>
-          <a:xfrm>
-            <a:off x="3323844" y="4105656"/>
-            <a:ext cx="2409444" cy="868680"/>
+              <a:t>Tốc độ phụ thuộc tuyệt đối vào số core CPU; không thể tăng tốc bằng cách đẻ thêm luồng.</a:t>
+            </a:r>
+            <a:endParaRPr lang="en-US" sz="1100" dirty="0"/>
+          </a:p>
+        </p:txBody>
+      </p:sp>
+      <p:sp>
+        <p:nvSpPr>
+          <p:cNvPr id="41" name="Shape 39"/>
+          <p:cNvSpPr/>
+          <p:nvPr/>
+        </p:nvSpPr>
+        <p:spPr>
+          <a:xfrm>
+            <a:off x="6455664" y="4078224"/>
+            <a:ext cx="4956048" cy="841248"/>
           </a:xfrm>
           <a:prstGeom prst="roundRect">
             <a:avLst>
-              <a:gd name="adj" fmla="val 8421"/>
+              <a:gd name="adj" fmla="val 8696"/>
             </a:avLst>
           </a:prstGeom>
           <a:solidFill>
@@ -19635,262 +20070,66 @@
       </p:sp>
       <p:sp>
         <p:nvSpPr>
-          <p:cNvPr id="29" name="Text 27"/>
-          <p:cNvSpPr/>
-          <p:nvPr/>
-        </p:nvSpPr>
-        <p:spPr>
-          <a:xfrm>
-            <a:off x="3415284" y="4178808"/>
-            <a:ext cx="2226564" cy="722376"/>
-          </a:xfrm>
-          <a:prstGeom prst="rect">
-            <a:avLst/>
-          </a:prstGeom>
-          <a:noFill/>
-          <a:ln/>
-        </p:spPr>
-        <p:txBody>
-          <a:bodyPr wrap="square" lIns="25400" tIns="50800" rIns="50800" bIns="25400" rtlCol="0" anchor="t"/>
-          <a:lstStyle/>
-          <a:p>
-            <a:pPr indent="0" marL="0">
-              <a:buNone/>
-            </a:pPr>
-            <a:r>
-              <a:rPr lang="en-US" sz="1000" b="1" dirty="0">
+          <p:cNvPr id="42" name="Text 40"/>
+          <p:cNvSpPr/>
+          <p:nvPr/>
+        </p:nvSpPr>
+        <p:spPr>
+          <a:xfrm>
+            <a:off x="6547104" y="4151376"/>
+            <a:ext cx="4773168" cy="694944"/>
+          </a:xfrm>
+          <a:prstGeom prst="rect">
+            <a:avLst/>
+          </a:prstGeom>
+          <a:noFill/>
+          <a:ln/>
+        </p:spPr>
+        <p:txBody>
+          <a:bodyPr wrap="square" lIns="25400" tIns="76200" rIns="76200" bIns="25400" rtlCol="0" anchor="ctr"/>
+          <a:lstStyle/>
+          <a:p>
+            <a:pPr indent="0" marL="0">
+              <a:buNone/>
+            </a:pPr>
+            <a:r>
+              <a:rPr lang="en-US" sz="1100" b="1" dirty="0">
                 <a:solidFill>
                   <a:srgbClr val="0F172A"/>
                 </a:solidFill>
               </a:rPr>
-              <a:t>⚡ Giải Pháp Đề Tài
+              <a:t>🔄  Tổn Thất Đổi Ngữ Cảnh
 </a:t>
             </a:r>
             <a:pPr indent="0" marL="0">
               <a:buNone/>
             </a:pPr>
             <a:r>
-              <a:rPr lang="en-US" sz="850" dirty="0">
+              <a:rPr lang="en-US" sz="920" dirty="0">
                 <a:solidFill>
                   <a:srgbClr val="334155"/>
                 </a:solidFill>
               </a:rPr>
-              <a:t>Ứng dụng Worker Thread Pool và Java 21 Virtual Threads để giải phóng sức mạnh máy chủ.</a:t>
-            </a:r>
-            <a:endParaRPr lang="en-US" sz="1000" dirty="0"/>
-          </a:p>
-        </p:txBody>
-      </p:sp>
-      <p:sp>
-        <p:nvSpPr>
-          <p:cNvPr id="30" name="Shape 28"/>
-          <p:cNvSpPr/>
-          <p:nvPr/>
-        </p:nvSpPr>
-        <p:spPr>
-          <a:xfrm>
-            <a:off x="777240" y="5084064"/>
+              <a:t>Quá nhiều luồng tranh chấp khiến CPU mất &gt;70% công suất chỉ để tráo Cache L1/L2.</a:t>
+            </a:r>
+            <a:endParaRPr lang="en-US" sz="1100" dirty="0"/>
+          </a:p>
+        </p:txBody>
+      </p:sp>
+      <p:sp>
+        <p:nvSpPr>
+          <p:cNvPr id="43" name="Shape 41"/>
+          <p:cNvSpPr/>
+          <p:nvPr/>
+        </p:nvSpPr>
+        <p:spPr>
+          <a:xfrm>
+            <a:off x="6455664" y="5084064"/>
             <a:ext cx="4956048" cy="365760"/>
           </a:xfrm>
           <a:prstGeom prst="roundRect">
             <a:avLst>
               <a:gd name="adj" fmla="val 20000"/>
-            </a:avLst>
-          </a:prstGeom>
-          <a:solidFill>
-            <a:srgbClr val="EFF6FF"/>
-          </a:solidFill>
-          <a:ln w="12700">
-            <a:solidFill>
-              <a:srgbClr val="BFDBFE"/>
-            </a:solidFill>
-            <a:prstDash val="solid"/>
-          </a:ln>
-        </p:spPr>
-      </p:sp>
-      <p:sp>
-        <p:nvSpPr>
-          <p:cNvPr id="31" name="Text 29"/>
-          <p:cNvSpPr/>
-          <p:nvPr/>
-        </p:nvSpPr>
-        <p:spPr>
-          <a:xfrm>
-            <a:off x="868680" y="5084064"/>
-            <a:ext cx="4773168" cy="365760"/>
-          </a:xfrm>
-          <a:prstGeom prst="rect">
-            <a:avLst/>
-          </a:prstGeom>
-          <a:noFill/>
-          <a:ln/>
-        </p:spPr>
-        <p:txBody>
-          <a:bodyPr wrap="square" rtlCol="0" anchor="ctr"/>
-          <a:lstStyle/>
-          <a:p>
-            <a:pPr indent="0" marL="0">
-              <a:buNone/>
-            </a:pPr>
-            <a:r>
-              <a:rPr lang="en-US" sz="880" b="1" dirty="0">
-                <a:solidFill>
-                  <a:srgbClr val="1D4ED8"/>
-                </a:solidFill>
-                <a:latin typeface="Arial" pitchFamily="34" charset="0"/>
-                <a:ea typeface="Arial" pitchFamily="34" charset="-122"/>
-                <a:cs typeface="Arial" pitchFamily="34" charset="-120"/>
-              </a:rPr>
-              <a:t>🚀 Sân khấu chính: Nơi Thread Pool &amp; Virtual Threads giải phóng sức mạnh máy chủ</a:t>
-            </a:r>
-            <a:endParaRPr lang="en-US" sz="880" dirty="0"/>
-          </a:p>
-        </p:txBody>
-      </p:sp>
-      <p:sp>
-        <p:nvSpPr>
-          <p:cNvPr id="32" name="Shape 30"/>
-          <p:cNvSpPr/>
-          <p:nvPr/>
-        </p:nvSpPr>
-        <p:spPr>
-          <a:xfrm>
-            <a:off x="6227064" y="1536192"/>
-            <a:ext cx="5413248" cy="4023360"/>
-          </a:xfrm>
-          <a:prstGeom prst="roundRect">
-            <a:avLst>
-              <a:gd name="adj" fmla="val 2273"/>
-            </a:avLst>
-          </a:prstGeom>
-          <a:solidFill>
-            <a:srgbClr val="FFFFFF"/>
-          </a:solidFill>
-          <a:ln w="19050">
-            <a:solidFill>
-              <a:srgbClr val="CBD5E1"/>
-            </a:solidFill>
-            <a:prstDash val="solid"/>
-          </a:ln>
-        </p:spPr>
-      </p:sp>
-      <p:sp>
-        <p:nvSpPr>
-          <p:cNvPr id="33" name="Shape 31"/>
-          <p:cNvSpPr/>
-          <p:nvPr/>
-        </p:nvSpPr>
-        <p:spPr>
-          <a:xfrm>
-            <a:off x="6227064" y="1536192"/>
-            <a:ext cx="5413248" cy="73152"/>
-          </a:xfrm>
-          <a:prstGeom prst="roundRect">
-            <a:avLst/>
-          </a:prstGeom>
-          <a:solidFill>
-            <a:srgbClr val="E11D48"/>
-          </a:solidFill>
-          <a:ln w="12700">
-            <a:solidFill>
-              <a:srgbClr val="E11D48"/>
-            </a:solidFill>
-            <a:prstDash val="solid"/>
-          </a:ln>
-        </p:spPr>
-      </p:sp>
-      <p:sp>
-        <p:nvSpPr>
-          <p:cNvPr id="34" name="Text 32"/>
-          <p:cNvSpPr/>
-          <p:nvPr/>
-        </p:nvSpPr>
-        <p:spPr>
-          <a:xfrm>
-            <a:off x="6455664" y="1673352"/>
-            <a:ext cx="3767328" cy="320040"/>
-          </a:xfrm>
-          <a:prstGeom prst="rect">
-            <a:avLst/>
-          </a:prstGeom>
-          <a:noFill/>
-          <a:ln/>
-        </p:spPr>
-        <p:txBody>
-          <a:bodyPr wrap="square" rtlCol="0" anchor="ctr"/>
-          <a:lstStyle/>
-          <a:p>
-            <a:pPr indent="0" marL="0">
-              <a:buNone/>
-            </a:pPr>
-            <a:r>
-              <a:rPr lang="en-US" sz="1450" b="1" dirty="0">
-                <a:solidFill>
-                  <a:srgbClr val="0F172A"/>
-                </a:solidFill>
-                <a:latin typeface="Arial" pitchFamily="34" charset="0"/>
-                <a:ea typeface="Arial" pitchFamily="34" charset="-122"/>
-                <a:cs typeface="Arial" pitchFamily="34" charset="-120"/>
-              </a:rPr>
-              <a:t>⚙️  Tác Vụ CPU-Bound</a:t>
-            </a:r>
-            <a:endParaRPr lang="en-US" sz="1450" dirty="0"/>
-          </a:p>
-        </p:txBody>
-      </p:sp>
-      <p:sp>
-        <p:nvSpPr>
-          <p:cNvPr id="35" name="Text 33"/>
-          <p:cNvSpPr/>
-          <p:nvPr/>
-        </p:nvSpPr>
-        <p:spPr>
-          <a:xfrm>
-            <a:off x="6455664" y="1993392"/>
-            <a:ext cx="3767328" cy="256032"/>
-          </a:xfrm>
-          <a:prstGeom prst="rect">
-            <a:avLst/>
-          </a:prstGeom>
-          <a:noFill/>
-          <a:ln/>
-        </p:spPr>
-        <p:txBody>
-          <a:bodyPr wrap="square" rtlCol="0" anchor="t"/>
-          <a:lstStyle/>
-          <a:p>
-            <a:pPr indent="0" marL="0">
-              <a:buNone/>
-            </a:pPr>
-            <a:r>
-              <a:rPr lang="en-US" sz="950" b="1" dirty="0">
-                <a:solidFill>
-                  <a:srgbClr val="334155"/>
-                </a:solidFill>
-                <a:latin typeface="Arial" pitchFamily="34" charset="0"/>
-                <a:ea typeface="Arial" pitchFamily="34" charset="-122"/>
-                <a:cs typeface="Arial" pitchFamily="34" charset="-120"/>
-              </a:rPr>
-              <a:t>Mã hóa SSL/TLS, Nén dữ liệu gzip, Thuật toán</a:t>
-            </a:r>
-            <a:endParaRPr lang="en-US" sz="950" dirty="0"/>
-          </a:p>
-        </p:txBody>
-      </p:sp>
-      <p:sp>
-        <p:nvSpPr>
-          <p:cNvPr id="36" name="Shape 34"/>
-          <p:cNvSpPr/>
-          <p:nvPr/>
-        </p:nvSpPr>
-        <p:spPr>
-          <a:xfrm>
-            <a:off x="9948672" y="1719072"/>
-            <a:ext cx="1463040" cy="256032"/>
-          </a:xfrm>
-          <a:prstGeom prst="roundRect">
-            <a:avLst>
-              <a:gd name="adj" fmla="val 35714"/>
             </a:avLst>
           </a:prstGeom>
           <a:solidFill>
@@ -19906,14 +20145,14 @@
       </p:sp>
       <p:sp>
         <p:nvSpPr>
-          <p:cNvPr id="37" name="Text 35"/>
-          <p:cNvSpPr/>
-          <p:nvPr/>
-        </p:nvSpPr>
-        <p:spPr>
-          <a:xfrm>
-            <a:off x="9948672" y="1719072"/>
-            <a:ext cx="1463040" cy="256032"/>
+          <p:cNvPr id="44" name="Text 42"/>
+          <p:cNvSpPr/>
+          <p:nvPr/>
+        </p:nvSpPr>
+        <p:spPr>
+          <a:xfrm>
+            <a:off x="6547104" y="5084064"/>
+            <a:ext cx="4773168" cy="365760"/>
           </a:xfrm>
           <a:prstGeom prst="rect">
             <a:avLst/>
@@ -19925,11 +20164,11 @@
           <a:bodyPr wrap="square" rtlCol="0" anchor="ctr"/>
           <a:lstStyle/>
           <a:p>
-            <a:pPr algn="ctr" indent="0" marL="0">
-              <a:buNone/>
-            </a:pPr>
-            <a:r>
-              <a:rPr lang="en-US" sz="800" b="1" dirty="0">
+            <a:pPr indent="0" marL="0">
+              <a:buNone/>
+            </a:pPr>
+            <a:r>
+              <a:rPr lang="en-US" sz="880" b="1" dirty="0">
                 <a:solidFill>
                   <a:srgbClr val="E11D48"/>
                 </a:solidFill>
@@ -19937,554 +20176,15 @@
                 <a:ea typeface="Arial" pitchFamily="34" charset="-122"/>
                 <a:cs typeface="Arial" pitchFamily="34" charset="-120"/>
               </a:rPr>
-              <a:t>10% — 20% TẢI MẠNG</a:t>
-            </a:r>
-            <a:endParaRPr lang="en-US" sz="800" dirty="0"/>
-          </a:p>
-        </p:txBody>
-      </p:sp>
-      <p:sp>
-        <p:nvSpPr>
-          <p:cNvPr id="38" name="Shape 36"/>
-          <p:cNvSpPr/>
-          <p:nvPr/>
-        </p:nvSpPr>
-        <p:spPr>
-          <a:xfrm>
-            <a:off x="6455664" y="2286000"/>
-            <a:ext cx="4956048" cy="0"/>
-          </a:xfrm>
-          <a:prstGeom prst="line">
-            <a:avLst/>
-          </a:prstGeom>
-          <a:noFill/>
-          <a:ln w="12700">
-            <a:solidFill>
-              <a:srgbClr val="F1F5F9"/>
-            </a:solidFill>
-            <a:prstDash val="solid"/>
-          </a:ln>
-        </p:spPr>
-      </p:sp>
-      <p:sp>
-        <p:nvSpPr>
-          <p:cNvPr id="39" name="Shape 37"/>
-          <p:cNvSpPr/>
-          <p:nvPr/>
-        </p:nvSpPr>
-        <p:spPr>
-          <a:xfrm>
-            <a:off x="6455664" y="2377440"/>
-            <a:ext cx="2386584" cy="658368"/>
-          </a:xfrm>
-          <a:prstGeom prst="roundRect">
-            <a:avLst>
-              <a:gd name="adj" fmla="val 11111"/>
-            </a:avLst>
-          </a:prstGeom>
-          <a:solidFill>
-            <a:srgbClr val="F8FAFC"/>
-          </a:solidFill>
-          <a:ln w="12700">
-            <a:solidFill>
-              <a:srgbClr val="CBD5E1"/>
-            </a:solidFill>
-            <a:prstDash val="solid"/>
-          </a:ln>
-        </p:spPr>
-      </p:sp>
-      <p:sp>
-        <p:nvSpPr>
-          <p:cNvPr id="40" name="Text 38"/>
-          <p:cNvSpPr/>
-          <p:nvPr/>
-        </p:nvSpPr>
-        <p:spPr>
-          <a:xfrm>
-            <a:off x="6547104" y="2432304"/>
-            <a:ext cx="2203704" cy="548640"/>
-          </a:xfrm>
-          <a:prstGeom prst="rect">
-            <a:avLst/>
-          </a:prstGeom>
-          <a:noFill/>
-          <a:ln/>
-        </p:spPr>
-        <p:txBody>
-          <a:bodyPr wrap="square" rtlCol="0" anchor="ctr"/>
-          <a:lstStyle/>
-          <a:p>
-            <a:pPr indent="0" marL="0">
-              <a:buNone/>
-            </a:pPr>
-            <a:r>
-              <a:rPr lang="en-US" sz="1600" b="1" dirty="0">
-                <a:solidFill>
-                  <a:srgbClr val="E11D48"/>
-                </a:solidFill>
-              </a:rPr>
-              <a:t>100%
-</a:t>
-            </a:r>
-            <a:pPr indent="0" marL="0">
-              <a:buNone/>
-            </a:pPr>
-            <a:r>
-              <a:rPr lang="en-US" sz="850" b="1" dirty="0">
-                <a:solidFill>
-                  <a:srgbClr val="334155"/>
-                </a:solidFill>
-              </a:rPr>
-              <a:t>Xung nhịp CPU hoạt động tối đa</a:t>
-            </a:r>
-            <a:endParaRPr lang="en-US" sz="1600" dirty="0"/>
-          </a:p>
-        </p:txBody>
-      </p:sp>
-      <p:sp>
-        <p:nvSpPr>
-          <p:cNvPr id="41" name="Shape 39"/>
-          <p:cNvSpPr/>
-          <p:nvPr/>
-        </p:nvSpPr>
-        <p:spPr>
-          <a:xfrm>
-            <a:off x="9025128" y="2377440"/>
-            <a:ext cx="2386584" cy="658368"/>
-          </a:xfrm>
-          <a:prstGeom prst="roundRect">
-            <a:avLst>
-              <a:gd name="adj" fmla="val 11111"/>
-            </a:avLst>
-          </a:prstGeom>
-          <a:solidFill>
-            <a:srgbClr val="F8FAFC"/>
-          </a:solidFill>
-          <a:ln w="12700">
-            <a:solidFill>
-              <a:srgbClr val="CBD5E1"/>
-            </a:solidFill>
-            <a:prstDash val="solid"/>
-          </a:ln>
-        </p:spPr>
-      </p:sp>
-      <p:sp>
-        <p:nvSpPr>
-          <p:cNvPr id="42" name="Text 40"/>
-          <p:cNvSpPr/>
-          <p:nvPr/>
-        </p:nvSpPr>
-        <p:spPr>
-          <a:xfrm>
-            <a:off x="9116568" y="2432304"/>
-            <a:ext cx="2203704" cy="548640"/>
-          </a:xfrm>
-          <a:prstGeom prst="rect">
-            <a:avLst/>
-          </a:prstGeom>
-          <a:noFill/>
-          <a:ln/>
-        </p:spPr>
-        <p:txBody>
-          <a:bodyPr wrap="square" rtlCol="0" anchor="ctr"/>
-          <a:lstStyle/>
-          <a:p>
-            <a:pPr indent="0" marL="0">
-              <a:buNone/>
-            </a:pPr>
-            <a:r>
-              <a:rPr lang="en-US" sz="1600" b="1" dirty="0">
-                <a:solidFill>
-                  <a:srgbClr val="E11D48"/>
-                </a:solidFill>
-              </a:rPr>
-              <a:t>N Lõi
-</a:t>
-            </a:r>
-            <a:pPr indent="0" marL="0">
-              <a:buNone/>
-            </a:pPr>
-            <a:r>
-              <a:rPr lang="en-US" sz="850" b="1" dirty="0">
-                <a:solidFill>
-                  <a:srgbClr val="334155"/>
-                </a:solidFill>
-              </a:rPr>
-              <a:t>Trần cứng giới hạn bởi số core vật lý</a:t>
-            </a:r>
-            <a:endParaRPr lang="en-US" sz="1600" dirty="0"/>
-          </a:p>
-        </p:txBody>
-      </p:sp>
-      <p:sp>
-        <p:nvSpPr>
-          <p:cNvPr id="43" name="Shape 41"/>
-          <p:cNvSpPr/>
-          <p:nvPr/>
-        </p:nvSpPr>
-        <p:spPr>
-          <a:xfrm>
-            <a:off x="6455664" y="3145536"/>
-            <a:ext cx="2409444" cy="868680"/>
-          </a:xfrm>
-          <a:prstGeom prst="roundRect">
-            <a:avLst>
-              <a:gd name="adj" fmla="val 8421"/>
-            </a:avLst>
-          </a:prstGeom>
-          <a:solidFill>
-            <a:srgbClr val="F8FAFC"/>
-          </a:solidFill>
-          <a:ln w="12700">
-            <a:solidFill>
-              <a:srgbClr val="E2E8F0"/>
-            </a:solidFill>
-            <a:prstDash val="solid"/>
-          </a:ln>
-        </p:spPr>
-      </p:sp>
-      <p:sp>
-        <p:nvSpPr>
-          <p:cNvPr id="44" name="Text 42"/>
-          <p:cNvSpPr/>
-          <p:nvPr/>
-        </p:nvSpPr>
-        <p:spPr>
-          <a:xfrm>
-            <a:off x="6547104" y="3218688"/>
-            <a:ext cx="2226564" cy="722376"/>
-          </a:xfrm>
-          <a:prstGeom prst="rect">
-            <a:avLst/>
-          </a:prstGeom>
-          <a:noFill/>
-          <a:ln/>
-        </p:spPr>
-        <p:txBody>
-          <a:bodyPr wrap="square" lIns="25400" tIns="50800" rIns="50800" bIns="25400" rtlCol="0" anchor="t"/>
-          <a:lstStyle/>
-          <a:p>
-            <a:pPr indent="0" marL="0">
-              <a:buNone/>
-            </a:pPr>
-            <a:r>
-              <a:rPr lang="en-US" sz="1000" b="1" dirty="0">
-                <a:solidFill>
-                  <a:srgbClr val="0F172A"/>
-                </a:solidFill>
-              </a:rPr>
-              <a:t>🧱 Ranh Giới Phần Cứng
-</a:t>
-            </a:r>
-            <a:pPr indent="0" marL="0">
-              <a:buNone/>
-            </a:pPr>
-            <a:r>
-              <a:rPr lang="en-US" sz="850" dirty="0">
-                <a:solidFill>
-                  <a:srgbClr val="334155"/>
-                </a:solidFill>
-              </a:rPr>
-              <a:t>Tốc độ xử lý phụ thuộc tuyệt đối vào số lõi CPU vật lý có sẵn trong máy chủ.</a:t>
-            </a:r>
-            <a:endParaRPr lang="en-US" sz="1000" dirty="0"/>
+              <a:t>🛡️ Cảnh báo thiết kế: Không thể tăng tốc CPU-Bound bằng cách đẻ thêm luồng</a:t>
+            </a:r>
+            <a:endParaRPr lang="en-US" sz="880" dirty="0"/>
           </a:p>
         </p:txBody>
       </p:sp>
       <p:sp>
         <p:nvSpPr>
           <p:cNvPr id="45" name="Shape 43"/>
-          <p:cNvSpPr/>
-          <p:nvPr/>
-        </p:nvSpPr>
-        <p:spPr>
-          <a:xfrm>
-            <a:off x="9002268" y="3145536"/>
-            <a:ext cx="2409444" cy="868680"/>
-          </a:xfrm>
-          <a:prstGeom prst="roundRect">
-            <a:avLst>
-              <a:gd name="adj" fmla="val 8421"/>
-            </a:avLst>
-          </a:prstGeom>
-          <a:solidFill>
-            <a:srgbClr val="F8FAFC"/>
-          </a:solidFill>
-          <a:ln w="12700">
-            <a:solidFill>
-              <a:srgbClr val="E2E8F0"/>
-            </a:solidFill>
-            <a:prstDash val="solid"/>
-          </a:ln>
-        </p:spPr>
-      </p:sp>
-      <p:sp>
-        <p:nvSpPr>
-          <p:cNvPr id="46" name="Text 44"/>
-          <p:cNvSpPr/>
-          <p:nvPr/>
-        </p:nvSpPr>
-        <p:spPr>
-          <a:xfrm>
-            <a:off x="9093708" y="3218688"/>
-            <a:ext cx="2226564" cy="722376"/>
-          </a:xfrm>
-          <a:prstGeom prst="rect">
-            <a:avLst/>
-          </a:prstGeom>
-          <a:noFill/>
-          <a:ln/>
-        </p:spPr>
-        <p:txBody>
-          <a:bodyPr wrap="square" lIns="25400" tIns="50800" rIns="50800" bIns="25400" rtlCol="0" anchor="t"/>
-          <a:lstStyle/>
-          <a:p>
-            <a:pPr indent="0" marL="0">
-              <a:buNone/>
-            </a:pPr>
-            <a:r>
-              <a:rPr lang="en-US" sz="1000" b="1" dirty="0">
-                <a:solidFill>
-                  <a:srgbClr val="0F172A"/>
-                </a:solidFill>
-              </a:rPr>
-              <a:t>⚠️ Nghịch Lý Tạo Luồng
-</a:t>
-            </a:r>
-            <a:pPr indent="0" marL="0">
-              <a:buNone/>
-            </a:pPr>
-            <a:r>
-              <a:rPr lang="en-US" sz="850" dirty="0">
-                <a:solidFill>
-                  <a:srgbClr val="334155"/>
-                </a:solidFill>
-              </a:rPr>
-              <a:t>Càng tạo thêm nhiều luồng vượt quá số lõi, hệ thống càng chậm do tranh chấp.</a:t>
-            </a:r>
-            <a:endParaRPr lang="en-US" sz="1000" dirty="0"/>
-          </a:p>
-        </p:txBody>
-      </p:sp>
-      <p:sp>
-        <p:nvSpPr>
-          <p:cNvPr id="47" name="Shape 45"/>
-          <p:cNvSpPr/>
-          <p:nvPr/>
-        </p:nvSpPr>
-        <p:spPr>
-          <a:xfrm>
-            <a:off x="6455664" y="4105656"/>
-            <a:ext cx="2409444" cy="868680"/>
-          </a:xfrm>
-          <a:prstGeom prst="roundRect">
-            <a:avLst>
-              <a:gd name="adj" fmla="val 8421"/>
-            </a:avLst>
-          </a:prstGeom>
-          <a:solidFill>
-            <a:srgbClr val="F8FAFC"/>
-          </a:solidFill>
-          <a:ln w="12700">
-            <a:solidFill>
-              <a:srgbClr val="E2E8F0"/>
-            </a:solidFill>
-            <a:prstDash val="solid"/>
-          </a:ln>
-        </p:spPr>
-      </p:sp>
-      <p:sp>
-        <p:nvSpPr>
-          <p:cNvPr id="48" name="Text 46"/>
-          <p:cNvSpPr/>
-          <p:nvPr/>
-        </p:nvSpPr>
-        <p:spPr>
-          <a:xfrm>
-            <a:off x="6547104" y="4178808"/>
-            <a:ext cx="2226564" cy="722376"/>
-          </a:xfrm>
-          <a:prstGeom prst="rect">
-            <a:avLst/>
-          </a:prstGeom>
-          <a:noFill/>
-          <a:ln/>
-        </p:spPr>
-        <p:txBody>
-          <a:bodyPr wrap="square" lIns="25400" tIns="50800" rIns="50800" bIns="25400" rtlCol="0" anchor="t"/>
-          <a:lstStyle/>
-          <a:p>
-            <a:pPr indent="0" marL="0">
-              <a:buNone/>
-            </a:pPr>
-            <a:r>
-              <a:rPr lang="en-US" sz="1000" b="1" dirty="0">
-                <a:solidFill>
-                  <a:srgbClr val="0F172A"/>
-                </a:solidFill>
-              </a:rPr>
-              <a:t>🔄 Phí Chuyển Ngữ Cảnh
-</a:t>
-            </a:r>
-            <a:pPr indent="0" marL="0">
-              <a:buNone/>
-            </a:pPr>
-            <a:r>
-              <a:rPr lang="en-US" sz="850" dirty="0">
-                <a:solidFill>
-                  <a:srgbClr val="334155"/>
-                </a:solidFill>
-              </a:rPr>
-              <a:t>CPU mất hơn 70% công suất chỉ để dọn và tráo đổi bộ nhớ đệm Cache L1/L2.</a:t>
-            </a:r>
-            <a:endParaRPr lang="en-US" sz="1000" dirty="0"/>
-          </a:p>
-        </p:txBody>
-      </p:sp>
-      <p:sp>
-        <p:nvSpPr>
-          <p:cNvPr id="49" name="Shape 47"/>
-          <p:cNvSpPr/>
-          <p:nvPr/>
-        </p:nvSpPr>
-        <p:spPr>
-          <a:xfrm>
-            <a:off x="9002268" y="4105656"/>
-            <a:ext cx="2409444" cy="868680"/>
-          </a:xfrm>
-          <a:prstGeom prst="roundRect">
-            <a:avLst>
-              <a:gd name="adj" fmla="val 8421"/>
-            </a:avLst>
-          </a:prstGeom>
-          <a:solidFill>
-            <a:srgbClr val="F8FAFC"/>
-          </a:solidFill>
-          <a:ln w="12700">
-            <a:solidFill>
-              <a:srgbClr val="E2E8F0"/>
-            </a:solidFill>
-            <a:prstDash val="solid"/>
-          </a:ln>
-        </p:spPr>
-      </p:sp>
-      <p:sp>
-        <p:nvSpPr>
-          <p:cNvPr id="50" name="Text 48"/>
-          <p:cNvSpPr/>
-          <p:nvPr/>
-        </p:nvSpPr>
-        <p:spPr>
-          <a:xfrm>
-            <a:off x="9093708" y="4178808"/>
-            <a:ext cx="2226564" cy="722376"/>
-          </a:xfrm>
-          <a:prstGeom prst="rect">
-            <a:avLst/>
-          </a:prstGeom>
-          <a:noFill/>
-          <a:ln/>
-        </p:spPr>
-        <p:txBody>
-          <a:bodyPr wrap="square" lIns="25400" tIns="50800" rIns="50800" bIns="25400" rtlCol="0" anchor="t"/>
-          <a:lstStyle/>
-          <a:p>
-            <a:pPr indent="0" marL="0">
-              <a:buNone/>
-            </a:pPr>
-            <a:r>
-              <a:rPr lang="en-US" sz="1000" b="1" dirty="0">
-                <a:solidFill>
-                  <a:srgbClr val="0F172A"/>
-                </a:solidFill>
-              </a:rPr>
-              <a:t>🛠️ Quy Tắc Thiết Kế
-</a:t>
-            </a:r>
-            <a:pPr indent="0" marL="0">
-              <a:buNone/>
-            </a:pPr>
-            <a:r>
-              <a:rPr lang="en-US" sz="850" dirty="0">
-                <a:solidFill>
-                  <a:srgbClr val="334155"/>
-                </a:solidFill>
-              </a:rPr>
-              <a:t>Giới hạn số luồng tối đa bằng đúng số Core phần cứng để đạt hiệu suất cao nhất.</a:t>
-            </a:r>
-            <a:endParaRPr lang="en-US" sz="1000" dirty="0"/>
-          </a:p>
-        </p:txBody>
-      </p:sp>
-      <p:sp>
-        <p:nvSpPr>
-          <p:cNvPr id="51" name="Shape 49"/>
-          <p:cNvSpPr/>
-          <p:nvPr/>
-        </p:nvSpPr>
-        <p:spPr>
-          <a:xfrm>
-            <a:off x="6455664" y="5084064"/>
-            <a:ext cx="4956048" cy="365760"/>
-          </a:xfrm>
-          <a:prstGeom prst="roundRect">
-            <a:avLst>
-              <a:gd name="adj" fmla="val 20000"/>
-            </a:avLst>
-          </a:prstGeom>
-          <a:solidFill>
-            <a:srgbClr val="FFF1F2"/>
-          </a:solidFill>
-          <a:ln w="12700">
-            <a:solidFill>
-              <a:srgbClr val="FECDD3"/>
-            </a:solidFill>
-            <a:prstDash val="solid"/>
-          </a:ln>
-        </p:spPr>
-      </p:sp>
-      <p:sp>
-        <p:nvSpPr>
-          <p:cNvPr id="52" name="Text 50"/>
-          <p:cNvSpPr/>
-          <p:nvPr/>
-        </p:nvSpPr>
-        <p:spPr>
-          <a:xfrm>
-            <a:off x="6547104" y="5084064"/>
-            <a:ext cx="4773168" cy="365760"/>
-          </a:xfrm>
-          <a:prstGeom prst="rect">
-            <a:avLst/>
-          </a:prstGeom>
-          <a:noFill/>
-          <a:ln/>
-        </p:spPr>
-        <p:txBody>
-          <a:bodyPr wrap="square" rtlCol="0" anchor="ctr"/>
-          <a:lstStyle/>
-          <a:p>
-            <a:pPr indent="0" marL="0">
-              <a:buNone/>
-            </a:pPr>
-            <a:r>
-              <a:rPr lang="en-US" sz="880" b="1" dirty="0">
-                <a:solidFill>
-                  <a:srgbClr val="E11D48"/>
-                </a:solidFill>
-                <a:latin typeface="Arial" pitchFamily="34" charset="0"/>
-                <a:ea typeface="Arial" pitchFamily="34" charset="-122"/>
-                <a:cs typeface="Arial" pitchFamily="34" charset="-120"/>
-              </a:rPr>
-              <a:t>🛡️ Cảnh báo thiết kế: Không thể tăng tốc CPU-Bound bằng cách đẻ thêm luồng</a:t>
-            </a:r>
-            <a:endParaRPr lang="en-US" sz="880" dirty="0"/>
-          </a:p>
-        </p:txBody>
-      </p:sp>
-      <p:sp>
-        <p:nvSpPr>
-          <p:cNvPr id="53" name="Shape 51"/>
           <p:cNvSpPr/>
           <p:nvPr/>
         </p:nvSpPr>
@@ -20511,7 +20211,7 @@
       </p:sp>
       <p:sp>
         <p:nvSpPr>
-          <p:cNvPr id="54" name="Shape 52"/>
+          <p:cNvPr id="46" name="Shape 44"/>
           <p:cNvSpPr/>
           <p:nvPr/>
         </p:nvSpPr>
@@ -20531,7 +20231,7 @@
       </p:sp>
       <p:sp>
         <p:nvSpPr>
-          <p:cNvPr id="55" name="Text 53"/>
+          <p:cNvPr id="47" name="Text 45"/>
           <p:cNvSpPr/>
           <p:nvPr/>
         </p:nvSpPr>

</xml_diff>